<commit_message>
Plan anual: el mismo Pro y Pro+, con cobro de 10 meses
El centro elige mensual o anual en los precios. El año cobra 10 meses y deja los mismos límites. Stripe usa un segundo Price ID por plan.

Co-authored-by: julio14-byte <julio14-byte@users.noreply.github.com>
</commit_message>
<xml_diff>
--- a/docs/pitch/crisvia-incubadora.pptx
+++ b/docs/pitch/crisvia-incubadora.pptx
@@ -5416,7 +5416,7 @@
                 </a:solidFill>
                 <a:latin typeface="Inter"/>
               </a:rPr>
-              <a:t>al mes, por site</a:t>
+              <a:t>al mes, o $1,490 al año</a:t>
             </a:r>
           </a:p>
         </p:txBody>
@@ -5608,7 +5608,7 @@
                 </a:solidFill>
                 <a:latin typeface="Inter"/>
               </a:rPr>
-              <a:t>al mes, por site</a:t>
+              <a:t>al mes, o $3,290 al año</a:t>
             </a:r>
           </a:p>
         </p:txBody>
@@ -5688,7 +5688,7 @@
                 </a:solidFill>
                 <a:latin typeface="Inter"/>
               </a:rPr>
-              <a:t>Precio por sitio. Se cancela cuando el centro quiere. Cobro con Stripe.</a:t>
+              <a:t>Precio por sitio. El año cobra 10 meses. Se cancela la renovación cuando el centro quiere.</a:t>
             </a:r>
           </a:p>
         </p:txBody>
@@ -8600,8 +8600,8 @@
         </p:nvSpPr>
         <p:spPr>
           <a:xfrm>
-            <a:off x="502920" y="1554480"/>
-            <a:ext cx="3566160" cy="4480560"/>
+            <a:off x="502920" y="1691640"/>
+            <a:ext cx="3566160" cy="4023360"/>
           </a:xfrm>
           <a:prstGeom prst="roundRect">
             <a:avLst>
@@ -8632,7 +8632,7 @@
         </p:nvSpPr>
         <p:spPr>
           <a:xfrm>
-            <a:off x="758952" y="1810512"/>
+            <a:off x="758952" y="1947672"/>
             <a:ext cx="3108960" cy="365760"/>
           </a:xfrm>
           <a:prstGeom prst="rect">
@@ -8672,8 +8672,8 @@
         </p:nvSpPr>
         <p:spPr>
           <a:xfrm>
-            <a:off x="758952" y="2267712"/>
-            <a:ext cx="3108960" cy="3520440"/>
+            <a:off x="758952" y="2404872"/>
+            <a:ext cx="3108960" cy="3063240"/>
           </a:xfrm>
           <a:prstGeom prst="rect">
             <a:avLst/>
@@ -8712,8 +8712,8 @@
         </p:nvSpPr>
         <p:spPr>
           <a:xfrm>
-            <a:off x="4297680" y="1554480"/>
-            <a:ext cx="3566160" cy="4480560"/>
+            <a:off x="4297680" y="1691640"/>
+            <a:ext cx="3566160" cy="4023360"/>
           </a:xfrm>
           <a:prstGeom prst="roundRect">
             <a:avLst>
@@ -8744,7 +8744,7 @@
         </p:nvSpPr>
         <p:spPr>
           <a:xfrm>
-            <a:off x="4553712" y="1810512"/>
+            <a:off x="4553712" y="1947672"/>
             <a:ext cx="3108960" cy="365760"/>
           </a:xfrm>
           <a:prstGeom prst="rect">
@@ -8784,8 +8784,8 @@
         </p:nvSpPr>
         <p:spPr>
           <a:xfrm>
-            <a:off x="4553712" y="2267712"/>
-            <a:ext cx="3108960" cy="3520440"/>
+            <a:off x="4553712" y="2404872"/>
+            <a:ext cx="3108960" cy="3063240"/>
           </a:xfrm>
           <a:prstGeom prst="rect">
             <a:avLst/>
@@ -8824,8 +8824,8 @@
         </p:nvSpPr>
         <p:spPr>
           <a:xfrm>
-            <a:off x="8092440" y="1554480"/>
-            <a:ext cx="3566160" cy="4480560"/>
+            <a:off x="8092440" y="1691640"/>
+            <a:ext cx="3566160" cy="4023360"/>
           </a:xfrm>
           <a:prstGeom prst="roundRect">
             <a:avLst>
@@ -8856,7 +8856,7 @@
         </p:nvSpPr>
         <p:spPr>
           <a:xfrm>
-            <a:off x="8348471" y="1810512"/>
+            <a:off x="8348471" y="1947672"/>
             <a:ext cx="3108960" cy="365760"/>
           </a:xfrm>
           <a:prstGeom prst="rect">
@@ -8896,8 +8896,8 @@
         </p:nvSpPr>
         <p:spPr>
           <a:xfrm>
-            <a:off x="8348471" y="2267712"/>
-            <a:ext cx="3108960" cy="3520440"/>
+            <a:off x="8348471" y="2404872"/>
+            <a:ext cx="3108960" cy="3063240"/>
           </a:xfrm>
           <a:prstGeom prst="rect">
             <a:avLst/>

</xml_diff>